<commit_message>
Add modules list code and day 5 presentation
</commit_message>
<xml_diff>
--- a/заняття_3_python_oop_django/презентація/django_lesson.pptx
+++ b/заняття_3_python_oop_django/презентація/django_lesson.pptx
@@ -2515,24 +2515,7 @@
                 <a:ea typeface="Consolas" pitchFamily="34" charset="-122"/>
                 <a:cs typeface="Consolas" pitchFamily="34" charset="-120"/>
               </a:rPr>
-              <a:t>    path('admin/', admin.site.urls),</a:t>
-            </a:r>
-            <a:endParaRPr lang="en-US" sz="1150" dirty="0"/>
-          </a:p>
-          <a:p>
-            <a:pPr marL="0" indent="0">
-              <a:buNone/>
-            </a:pPr>
-            <a:r>
-              <a:rPr lang="en-US" sz="1150" dirty="0">
-                <a:solidFill>
-                  <a:srgbClr val="A3E635"/>
-                </a:solidFill>
-                <a:latin typeface="Consolas" pitchFamily="34" charset="0"/>
-                <a:ea typeface="Consolas" pitchFamily="34" charset="-122"/>
-                <a:cs typeface="Consolas" pitchFamily="34" charset="-120"/>
-              </a:rPr>
-              <a:t>    path('', views.home),</a:t>
+              <a:t>    path(’home/’, views.home),</a:t>
             </a:r>
             <a:endParaRPr lang="en-US" sz="1150" dirty="0"/>
           </a:p>
@@ -2697,7 +2680,7 @@
                 <a:ea typeface="Consolas" pitchFamily="34" charset="-122"/>
                 <a:cs typeface="Consolas" pitchFamily="34" charset="-120"/>
               </a:rPr>
-              <a:t>http://localhost:8000/about/</a:t>
+              <a:t>http://localhost:8000/courses/about/</a:t>
             </a:r>
             <a:r>
               <a:rPr lang="en-US" sz="1200" dirty="0">
@@ -7607,7 +7590,7 @@
                 <a:ea typeface="Consolas" pitchFamily="34" charset="-122"/>
                 <a:cs typeface="Consolas" pitchFamily="34" charset="-120"/>
               </a:rPr>
-              <a:t>$ django-admin startproject mysite .</a:t>
+              <a:t>$ django-admin startproject edu_platform .</a:t>
             </a:r>
             <a:endParaRPr lang="en-US" sz="2200" dirty="0"/>
           </a:p>
@@ -7752,7 +7735,7 @@
                 <a:ea typeface="Consolas" pitchFamily="34" charset="-122"/>
                 <a:cs typeface="Consolas" pitchFamily="34" charset="-120"/>
               </a:rPr>
-              <a:t>mysite/</a:t>
+              <a:t>edu_platform/</a:t>
             </a:r>
             <a:endParaRPr lang="en-US" sz="1250" dirty="0"/>
           </a:p>
@@ -7786,7 +7769,7 @@
                 <a:ea typeface="Consolas" pitchFamily="34" charset="-122"/>
                 <a:cs typeface="Consolas" pitchFamily="34" charset="-120"/>
               </a:rPr>
-              <a:t>└── mysite/</a:t>
+              <a:t>└── edu_platform/</a:t>
             </a:r>
             <a:endParaRPr lang="en-US" sz="1250" dirty="0"/>
           </a:p>
@@ -10768,7 +10751,7 @@
                 <a:ea typeface="Consolas" pitchFamily="34" charset="-122"/>
                 <a:cs typeface="Consolas" pitchFamily="34" charset="-120"/>
               </a:rPr>
-              <a:t>$ python manage.py startapp pages</a:t>
+              <a:t>$ python manage.py startapp courses</a:t>
             </a:r>
             <a:endParaRPr lang="en-US" sz="2100" dirty="0"/>
           </a:p>
@@ -10877,7 +10860,7 @@
                 <a:ea typeface="Consolas" pitchFamily="34" charset="-122"/>
                 <a:cs typeface="Consolas" pitchFamily="34" charset="-120"/>
               </a:rPr>
-              <a:t>pages/</a:t>
+              <a:t>courses/</a:t>
             </a:r>
             <a:endParaRPr lang="en-US" sz="1150" dirty="0"/>
           </a:p>
@@ -11204,7 +11187,7 @@
                 <a:ea typeface="Consolas" pitchFamily="34" charset="-122"/>
                 <a:cs typeface="Consolas" pitchFamily="34" charset="-120"/>
               </a:rPr>
-              <a:t>    'pages',   # ← додати!</a:t>
+              <a:t>    ‘courses',   # ← додати!</a:t>
             </a:r>
             <a:endParaRPr lang="en-US" sz="1200" dirty="0"/>
           </a:p>
@@ -11453,29 +11436,7 @@
                 <a:ea typeface="Consolas" pitchFamily="34" charset="-122"/>
                 <a:cs typeface="Consolas" pitchFamily="34" charset="-120"/>
               </a:rPr>
-              <a:t>from </a:t>
-            </a:r>
-            <a:r>
-              <a:rPr lang="en-US" sz="1250" dirty="0" err="1">
-                <a:solidFill>
-                  <a:srgbClr val="A3E635"/>
-                </a:solidFill>
-                <a:latin typeface="Consolas" pitchFamily="34" charset="0"/>
-                <a:ea typeface="Consolas" pitchFamily="34" charset="-122"/>
-                <a:cs typeface="Consolas" pitchFamily="34" charset="-120"/>
-              </a:rPr>
-              <a:t>django.http</a:t>
-            </a:r>
-            <a:r>
-              <a:rPr lang="en-US" sz="1250" dirty="0">
-                <a:solidFill>
-                  <a:srgbClr val="A3E635"/>
-                </a:solidFill>
-                <a:latin typeface="Consolas" pitchFamily="34" charset="0"/>
-                <a:ea typeface="Consolas" pitchFamily="34" charset="-122"/>
-                <a:cs typeface="Consolas" pitchFamily="34" charset="-120"/>
-              </a:rPr>
-              <a:t> import HttpResponse</a:t>
+              <a:t>from django.http import HttpResponse</a:t>
             </a:r>
             <a:endParaRPr lang="en-US" sz="1250" dirty="0"/>
           </a:p>
@@ -11691,10 +11652,16 @@
                 <a:ea typeface="Consolas" pitchFamily="34" charset="-122"/>
                 <a:cs typeface="Consolas" pitchFamily="34" charset="-120"/>
               </a:rPr>
-              <a:t>from </a:t>
-            </a:r>
-            <a:r>
-              <a:rPr lang="en-US" sz="1200" dirty="0" err="1">
+              <a:t>from django.contrib import admin</a:t>
+            </a:r>
+            <a:endParaRPr lang="en-US" sz="1200" dirty="0"/>
+          </a:p>
+          <a:p>
+            <a:pPr marL="0" indent="0">
+              <a:buNone/>
+            </a:pPr>
+            <a:r>
+              <a:rPr lang="en-US" sz="1200" dirty="0">
                 <a:solidFill>
                   <a:srgbClr val="A3E635"/>
                 </a:solidFill>
@@ -11702,8 +11669,14 @@
                 <a:ea typeface="Consolas" pitchFamily="34" charset="-122"/>
                 <a:cs typeface="Consolas" pitchFamily="34" charset="-120"/>
               </a:rPr>
-              <a:t>django.contrib</a:t>
-            </a:r>
+              <a:t>from django.urls import path</a:t>
+            </a:r>
+            <a:endParaRPr lang="en-US" sz="1200" dirty="0"/>
+          </a:p>
+          <a:p>
+            <a:pPr marL="0" indent="0">
+              <a:buNone/>
+            </a:pPr>
             <a:r>
               <a:rPr lang="en-US" sz="1200" dirty="0">
                 <a:solidFill>
@@ -11713,63 +11686,7 @@
                 <a:ea typeface="Consolas" pitchFamily="34" charset="-122"/>
                 <a:cs typeface="Consolas" pitchFamily="34" charset="-120"/>
               </a:rPr>
-              <a:t> import admin</a:t>
-            </a:r>
-            <a:endParaRPr lang="en-US" sz="1200" dirty="0"/>
-          </a:p>
-          <a:p>
-            <a:pPr marL="0" indent="0">
-              <a:buNone/>
-            </a:pPr>
-            <a:r>
-              <a:rPr lang="en-US" sz="1200" dirty="0">
-                <a:solidFill>
-                  <a:srgbClr val="A3E635"/>
-                </a:solidFill>
-                <a:latin typeface="Consolas" pitchFamily="34" charset="0"/>
-                <a:ea typeface="Consolas" pitchFamily="34" charset="-122"/>
-                <a:cs typeface="Consolas" pitchFamily="34" charset="-120"/>
-              </a:rPr>
-              <a:t>from </a:t>
-            </a:r>
-            <a:r>
-              <a:rPr lang="en-US" sz="1200" dirty="0" err="1">
-                <a:solidFill>
-                  <a:srgbClr val="A3E635"/>
-                </a:solidFill>
-                <a:latin typeface="Consolas" pitchFamily="34" charset="0"/>
-                <a:ea typeface="Consolas" pitchFamily="34" charset="-122"/>
-                <a:cs typeface="Consolas" pitchFamily="34" charset="-120"/>
-              </a:rPr>
-              <a:t>django.urls</a:t>
-            </a:r>
-            <a:r>
-              <a:rPr lang="en-US" sz="1200" dirty="0">
-                <a:solidFill>
-                  <a:srgbClr val="A3E635"/>
-                </a:solidFill>
-                <a:latin typeface="Consolas" pitchFamily="34" charset="0"/>
-                <a:ea typeface="Consolas" pitchFamily="34" charset="-122"/>
-                <a:cs typeface="Consolas" pitchFamily="34" charset="-120"/>
-              </a:rPr>
-              <a:t> import path</a:t>
-            </a:r>
-            <a:endParaRPr lang="en-US" sz="1200" dirty="0"/>
-          </a:p>
-          <a:p>
-            <a:pPr marL="0" indent="0">
-              <a:buNone/>
-            </a:pPr>
-            <a:r>
-              <a:rPr lang="en-US" sz="1200" dirty="0">
-                <a:solidFill>
-                  <a:srgbClr val="A3E635"/>
-                </a:solidFill>
-                <a:latin typeface="Consolas" pitchFamily="34" charset="0"/>
-                <a:ea typeface="Consolas" pitchFamily="34" charset="-122"/>
-                <a:cs typeface="Consolas" pitchFamily="34" charset="-120"/>
-              </a:rPr>
-              <a:t>from pages import views</a:t>
+              <a:t>from courses import views</a:t>
             </a:r>
             <a:endParaRPr lang="en-US" sz="1200" dirty="0"/>
           </a:p>

</xml_diff>